<commit_message>
[UPD] Presentation: Update Presentation
</commit_message>
<xml_diff>
--- a/PSI Team_Quantum Cryptography.pptx
+++ b/PSI Team_Quantum Cryptography.pptx
@@ -12,8 +12,8 @@
     <p:sldId id="258" r:id="rId3"/>
     <p:sldId id="276" r:id="rId4"/>
     <p:sldId id="257" r:id="rId5"/>
-    <p:sldId id="272" r:id="rId6"/>
-    <p:sldId id="259" r:id="rId7"/>
+    <p:sldId id="259" r:id="rId6"/>
+    <p:sldId id="272" r:id="rId7"/>
     <p:sldId id="275" r:id="rId8"/>
     <p:sldId id="278" r:id="rId9"/>
     <p:sldId id="280" r:id="rId10"/>
@@ -199,7 +199,7 @@
   <pc:docChgLst>
     <pc:chgData name="Esraa Mohamed" userId="3a8d9ba6c86229f9" providerId="LiveId" clId="{9E4C49A7-7ED7-4338-BF1B-D37B453EC31A}"/>
     <pc:docChg chg="undo redo custSel addSld delSld modSld sldOrd">
-      <pc:chgData name="Esraa Mohamed" userId="3a8d9ba6c86229f9" providerId="LiveId" clId="{9E4C49A7-7ED7-4338-BF1B-D37B453EC31A}" dt="2026-09-08T09:44:11.643" v="1061" actId="20577"/>
+      <pc:chgData name="Esraa Mohamed" userId="3a8d9ba6c86229f9" providerId="LiveId" clId="{9E4C49A7-7ED7-4338-BF1B-D37B453EC31A}" dt="2026-09-08T10:47:41.766" v="1097" actId="20577"/>
       <pc:docMkLst>
         <pc:docMk/>
       </pc:docMkLst>
@@ -337,7 +337,7 @@
         </pc:picChg>
       </pc:sldChg>
       <pc:sldChg chg="addSp delSp modSp mod">
-        <pc:chgData name="Esraa Mohamed" userId="3a8d9ba6c86229f9" providerId="LiveId" clId="{9E4C49A7-7ED7-4338-BF1B-D37B453EC31A}" dt="2026-09-08T09:42:02.319" v="1051" actId="403"/>
+        <pc:chgData name="Esraa Mohamed" userId="3a8d9ba6c86229f9" providerId="LiveId" clId="{9E4C49A7-7ED7-4338-BF1B-D37B453EC31A}" dt="2026-09-08T10:42:14.283" v="1090" actId="22"/>
         <pc:sldMkLst>
           <pc:docMk/>
           <pc:sldMk cId="0" sldId="259"/>
@@ -359,7 +359,7 @@
           </ac:spMkLst>
         </pc:spChg>
         <pc:spChg chg="mod">
-          <ac:chgData name="Esraa Mohamed" userId="3a8d9ba6c86229f9" providerId="LiveId" clId="{9E4C49A7-7ED7-4338-BF1B-D37B453EC31A}" dt="2026-09-08T01:45:19.697" v="331" actId="1076"/>
+          <ac:chgData name="Esraa Mohamed" userId="3a8d9ba6c86229f9" providerId="LiveId" clId="{9E4C49A7-7ED7-4338-BF1B-D37B453EC31A}" dt="2026-09-08T10:41:31.806" v="1081" actId="20577"/>
           <ac:spMkLst>
             <pc:docMk/>
             <pc:sldMk cId="0" sldId="259"/>
@@ -367,7 +367,7 @@
           </ac:spMkLst>
         </pc:spChg>
         <pc:spChg chg="mod">
-          <ac:chgData name="Esraa Mohamed" userId="3a8d9ba6c86229f9" providerId="LiveId" clId="{9E4C49A7-7ED7-4338-BF1B-D37B453EC31A}" dt="2026-09-08T08:32:11.823" v="708" actId="14100"/>
+          <ac:chgData name="Esraa Mohamed" userId="3a8d9ba6c86229f9" providerId="LiveId" clId="{9E4C49A7-7ED7-4338-BF1B-D37B453EC31A}" dt="2026-09-08T10:39:26.872" v="1066" actId="20577"/>
           <ac:spMkLst>
             <pc:docMk/>
             <pc:sldMk cId="0" sldId="259"/>
@@ -388,6 +388,14 @@
             <pc:docMk/>
             <pc:sldMk cId="0" sldId="259"/>
             <ac:picMk id="8" creationId="{830DCDB1-B6BB-E7E5-4E58-E24ACA2E2CD1}"/>
+          </ac:picMkLst>
+        </pc:picChg>
+        <pc:picChg chg="add del mod">
+          <ac:chgData name="Esraa Mohamed" userId="3a8d9ba6c86229f9" providerId="LiveId" clId="{9E4C49A7-7ED7-4338-BF1B-D37B453EC31A}" dt="2026-09-08T10:42:14.283" v="1090" actId="22"/>
+          <ac:picMkLst>
+            <pc:docMk/>
+            <pc:sldMk cId="0" sldId="259"/>
+            <ac:picMk id="9" creationId="{410E699E-062D-14F1-2773-442508BE51A6}"/>
           </ac:picMkLst>
         </pc:picChg>
       </pc:sldChg>
@@ -665,14 +673,14 @@
           </ac:picMkLst>
         </pc:picChg>
       </pc:sldChg>
-      <pc:sldChg chg="addSp modSp mod">
-        <pc:chgData name="Esraa Mohamed" userId="3a8d9ba6c86229f9" providerId="LiveId" clId="{9E4C49A7-7ED7-4338-BF1B-D37B453EC31A}" dt="2026-09-08T09:39:29.470" v="1006" actId="1076"/>
+      <pc:sldChg chg="addSp modSp mod ord">
+        <pc:chgData name="Esraa Mohamed" userId="3a8d9ba6c86229f9" providerId="LiveId" clId="{9E4C49A7-7ED7-4338-BF1B-D37B453EC31A}" dt="2026-09-08T10:39:53.882" v="1071"/>
         <pc:sldMkLst>
           <pc:docMk/>
           <pc:sldMk cId="2055683795" sldId="272"/>
         </pc:sldMkLst>
         <pc:spChg chg="mod">
-          <ac:chgData name="Esraa Mohamed" userId="3a8d9ba6c86229f9" providerId="LiveId" clId="{9E4C49A7-7ED7-4338-BF1B-D37B453EC31A}" dt="2026-09-08T08:31:56.243" v="704" actId="14100"/>
+          <ac:chgData name="Esraa Mohamed" userId="3a8d9ba6c86229f9" providerId="LiveId" clId="{9E4C49A7-7ED7-4338-BF1B-D37B453EC31A}" dt="2026-09-08T10:39:21.324" v="1064" actId="20577"/>
           <ac:spMkLst>
             <pc:docMk/>
             <pc:sldMk cId="2055683795" sldId="272"/>
@@ -790,8 +798,8 @@
           <pc:sldMk cId="624070312" sldId="274"/>
         </pc:sldMkLst>
       </pc:sldChg>
-      <pc:sldChg chg="addSp delSp modSp add mod">
-        <pc:chgData name="Esraa Mohamed" userId="3a8d9ba6c86229f9" providerId="LiveId" clId="{9E4C49A7-7ED7-4338-BF1B-D37B453EC31A}" dt="2026-09-08T09:44:11.643" v="1061" actId="20577"/>
+      <pc:sldChg chg="addSp delSp modSp add mod ord">
+        <pc:chgData name="Esraa Mohamed" userId="3a8d9ba6c86229f9" providerId="LiveId" clId="{9E4C49A7-7ED7-4338-BF1B-D37B453EC31A}" dt="2026-09-08T10:42:14.689" v="1091" actId="21"/>
         <pc:sldMkLst>
           <pc:docMk/>
           <pc:sldMk cId="350956906" sldId="275"/>
@@ -876,8 +884,8 @@
             <ac:picMk id="8" creationId="{40E967A8-1B07-F63A-A85F-A69198C0B560}"/>
           </ac:picMkLst>
         </pc:picChg>
-        <pc:picChg chg="add mod">
-          <ac:chgData name="Esraa Mohamed" userId="3a8d9ba6c86229f9" providerId="LiveId" clId="{9E4C49A7-7ED7-4338-BF1B-D37B453EC31A}" dt="2026-09-08T09:28:00.650" v="957" actId="1076"/>
+        <pc:picChg chg="add del mod">
+          <ac:chgData name="Esraa Mohamed" userId="3a8d9ba6c86229f9" providerId="LiveId" clId="{9E4C49A7-7ED7-4338-BF1B-D37B453EC31A}" dt="2026-09-08T10:42:14.689" v="1091" actId="21"/>
           <ac:picMkLst>
             <pc:docMk/>
             <pc:sldMk cId="350956906" sldId="275"/>
@@ -932,7 +940,7 @@
         </pc:sldMkLst>
       </pc:sldChg>
       <pc:sldChg chg="addSp delSp modSp add mod">
-        <pc:chgData name="Esraa Mohamed" userId="3a8d9ba6c86229f9" providerId="LiveId" clId="{9E4C49A7-7ED7-4338-BF1B-D37B453EC31A}" dt="2026-09-08T09:42:50.813" v="1053" actId="478"/>
+        <pc:chgData name="Esraa Mohamed" userId="3a8d9ba6c86229f9" providerId="LiveId" clId="{9E4C49A7-7ED7-4338-BF1B-D37B453EC31A}" dt="2026-09-08T10:47:41.766" v="1097" actId="20577"/>
         <pc:sldMkLst>
           <pc:docMk/>
           <pc:sldMk cId="2416215152" sldId="278"/>
@@ -986,7 +994,7 @@
           </ac:spMkLst>
         </pc:spChg>
         <pc:spChg chg="add mod">
-          <ac:chgData name="Esraa Mohamed" userId="3a8d9ba6c86229f9" providerId="LiveId" clId="{9E4C49A7-7ED7-4338-BF1B-D37B453EC31A}" dt="2026-09-08T09:36:54.306" v="999" actId="20577"/>
+          <ac:chgData name="Esraa Mohamed" userId="3a8d9ba6c86229f9" providerId="LiveId" clId="{9E4C49A7-7ED7-4338-BF1B-D37B453EC31A}" dt="2026-09-08T10:47:41.766" v="1097" actId="20577"/>
           <ac:spMkLst>
             <pc:docMk/>
             <pc:sldMk cId="2416215152" sldId="278"/>
@@ -1096,7 +1104,7 @@
         </pc:picChg>
       </pc:sldChg>
       <pc:sldChg chg="delSp modSp add mod setBg">
-        <pc:chgData name="Esraa Mohamed" userId="3a8d9ba6c86229f9" providerId="LiveId" clId="{9E4C49A7-7ED7-4338-BF1B-D37B453EC31A}" dt="2026-09-08T09:25:47.970" v="945" actId="2711"/>
+        <pc:chgData name="Esraa Mohamed" userId="3a8d9ba6c86229f9" providerId="LiveId" clId="{9E4C49A7-7ED7-4338-BF1B-D37B453EC31A}" dt="2026-09-08T09:50:34.244" v="1062" actId="20577"/>
         <pc:sldMkLst>
           <pc:docMk/>
           <pc:sldMk cId="3589464526" sldId="281"/>
@@ -1110,7 +1118,7 @@
           </ac:spMkLst>
         </pc:spChg>
         <pc:spChg chg="mod">
-          <ac:chgData name="Esraa Mohamed" userId="3a8d9ba6c86229f9" providerId="LiveId" clId="{9E4C49A7-7ED7-4338-BF1B-D37B453EC31A}" dt="2026-09-08T09:25:47.970" v="945" actId="2711"/>
+          <ac:chgData name="Esraa Mohamed" userId="3a8d9ba6c86229f9" providerId="LiveId" clId="{9E4C49A7-7ED7-4338-BF1B-D37B453EC31A}" dt="2026-09-08T09:50:34.244" v="1062" actId="20577"/>
           <ac:spMkLst>
             <pc:docMk/>
             <pc:sldMk cId="3589464526" sldId="281"/>
@@ -10626,7 +10634,7 @@
               <a:rPr lang="en-GB" sz="2800" dirty="0">
                 <a:latin typeface="Abadi" panose="020B0604020104020204" pitchFamily="34" charset="0"/>
               </a:rPr>
-              <a:t> 20 Monte Carlo trials smooth out fluctuations and improve result reliability. </a:t>
+              <a:t> 20 trials smooth out fluctuations and improve result reliability. </a:t>
             </a:r>
           </a:p>
         </p:txBody>
@@ -12309,6 +12317,424 @@
 <file path=ppt/slides/slide5.xml><?xml version="1.0" encoding="utf-8"?>
 <p:sld xmlns:a="http://schemas.openxmlformats.org/drawingml/2006/main" xmlns:r="http://schemas.openxmlformats.org/officeDocument/2006/relationships" xmlns:p="http://schemas.openxmlformats.org/presentationml/2006/main">
   <p:cSld>
+    <p:bg>
+      <p:bgPr>
+        <a:solidFill>
+          <a:srgbClr val="E9EAE0"/>
+        </a:solidFill>
+        <a:effectLst/>
+      </p:bgPr>
+    </p:bg>
+    <p:spTree>
+      <p:nvGrpSpPr>
+        <p:cNvPr id="1" name=""/>
+        <p:cNvGrpSpPr/>
+        <p:nvPr/>
+      </p:nvGrpSpPr>
+      <p:grpSpPr>
+        <a:xfrm>
+          <a:off x="0" y="0"/>
+          <a:ext cx="0" cy="0"/>
+          <a:chOff x="0" y="0"/>
+          <a:chExt cx="0" cy="0"/>
+        </a:xfrm>
+      </p:grpSpPr>
+      <p:sp>
+        <p:nvSpPr>
+          <p:cNvPr id="4" name="Freeform 4"/>
+          <p:cNvSpPr/>
+          <p:nvPr/>
+        </p:nvSpPr>
+        <p:spPr>
+          <a:xfrm flipH="1">
+            <a:off x="11415085" y="-545920"/>
+            <a:ext cx="28550447" cy="11313545"/>
+          </a:xfrm>
+          <a:custGeom>
+            <a:avLst/>
+            <a:gdLst/>
+            <a:ahLst/>
+            <a:cxnLst/>
+            <a:rect l="l" t="t" r="r" b="b"/>
+            <a:pathLst>
+              <a:path w="28550447" h="11313545">
+                <a:moveTo>
+                  <a:pt x="28550447" y="0"/>
+                </a:moveTo>
+                <a:lnTo>
+                  <a:pt x="0" y="0"/>
+                </a:lnTo>
+                <a:lnTo>
+                  <a:pt x="0" y="11313545"/>
+                </a:lnTo>
+                <a:lnTo>
+                  <a:pt x="28550447" y="11313545"/>
+                </a:lnTo>
+                <a:lnTo>
+                  <a:pt x="28550447" y="0"/>
+                </a:lnTo>
+                <a:close/>
+              </a:path>
+            </a:pathLst>
+          </a:custGeom>
+          <a:blipFill>
+            <a:blip>
+              <a:extLst>
+                <a:ext uri="{96DAC541-7B7A-43D3-8B79-37D633B846F1}">
+                  <asvg:svgBlip xmlns:asvg="http://schemas.microsoft.com/office/drawing/2016/SVG/main" r:embed="rId2"/>
+                </a:ext>
+              </a:extLst>
+            </a:blip>
+            <a:stretch>
+              <a:fillRect t="-49969" b="-59256"/>
+            </a:stretch>
+          </a:blipFill>
+        </p:spPr>
+        <p:txBody>
+          <a:bodyPr/>
+          <a:lstStyle/>
+          <a:p>
+            <a:endParaRPr lang="en-GB"/>
+          </a:p>
+        </p:txBody>
+      </p:sp>
+      <p:sp>
+        <p:nvSpPr>
+          <p:cNvPr id="6" name="Google Shape;1606;p38">
+            <a:extLst>
+              <a:ext uri="{FF2B5EF4-FFF2-40B4-BE49-F238E27FC236}">
+                <a16:creationId xmlns:a16="http://schemas.microsoft.com/office/drawing/2014/main" id="{11940575-107A-ADA6-174F-56482EB05298}"/>
+              </a:ext>
+            </a:extLst>
+          </p:cNvPr>
+          <p:cNvSpPr txBox="1"/>
+          <p:nvPr/>
+        </p:nvSpPr>
+        <p:spPr>
+          <a:xfrm>
+            <a:off x="6324600" y="3004257"/>
+            <a:ext cx="7746330" cy="704636"/>
+          </a:xfrm>
+          <a:prstGeom prst="rect">
+            <a:avLst/>
+          </a:prstGeom>
+          <a:noFill/>
+          <a:ln>
+            <a:noFill/>
+          </a:ln>
+        </p:spPr>
+        <p:txBody>
+          <a:bodyPr spcFirstLastPara="1" wrap="square" lIns="121900" tIns="121900" rIns="121900" bIns="121900" anchor="t" anchorCtr="0">
+            <a:noAutofit/>
+          </a:bodyPr>
+          <a:lstStyle/>
+          <a:p>
+            <a:pPr algn="ctr" defTabSz="1219170">
+              <a:buClr>
+                <a:srgbClr val="000000"/>
+              </a:buClr>
+            </a:pPr>
+            <a:r>
+              <a:rPr lang="en-GB" sz="2800" b="1" kern="0" dirty="0">
+                <a:solidFill>
+                  <a:srgbClr val="000000"/>
+                </a:solidFill>
+                <a:latin typeface="Berlin Sans FB Demi" panose="020E0802020502020306" pitchFamily="34" charset="0"/>
+                <a:cs typeface="Arial"/>
+                <a:sym typeface="Arial"/>
+              </a:rPr>
+              <a:t>Build → Attack/Noise → Detect → </a:t>
+            </a:r>
+            <a:r>
+              <a:rPr lang="en-GB" sz="2800" b="1" kern="0" dirty="0" err="1">
+                <a:solidFill>
+                  <a:srgbClr val="000000"/>
+                </a:solidFill>
+                <a:latin typeface="Berlin Sans FB Demi" panose="020E0802020502020306" pitchFamily="34" charset="0"/>
+                <a:cs typeface="Arial"/>
+                <a:sym typeface="Arial"/>
+              </a:rPr>
+              <a:t>Distill</a:t>
+            </a:r>
+            <a:endParaRPr lang="en-GB" sz="2800" b="1" kern="0" dirty="0">
+              <a:solidFill>
+                <a:srgbClr val="000000"/>
+              </a:solidFill>
+              <a:latin typeface="Berlin Sans FB Demi" panose="020E0802020502020306" pitchFamily="34" charset="0"/>
+              <a:cs typeface="Arial"/>
+              <a:sym typeface="Arial"/>
+            </a:endParaRPr>
+          </a:p>
+          <a:p>
+            <a:pPr defTabSz="1219170">
+              <a:buClr>
+                <a:srgbClr val="000000"/>
+              </a:buClr>
+            </a:pPr>
+            <a:endParaRPr lang="en-GB" sz="2000" kern="0" dirty="0">
+              <a:solidFill>
+                <a:srgbClr val="000000"/>
+              </a:solidFill>
+              <a:latin typeface="Arial"/>
+              <a:cs typeface="Arial"/>
+              <a:sym typeface="Arial"/>
+            </a:endParaRPr>
+          </a:p>
+          <a:p>
+            <a:pPr marL="380990" indent="-380990" defTabSz="1219170">
+              <a:buClr>
+                <a:srgbClr val="000000"/>
+              </a:buClr>
+              <a:buFont typeface="Arial" panose="020B0604020202020204" pitchFamily="34" charset="0"/>
+              <a:buChar char="•"/>
+            </a:pPr>
+            <a:endParaRPr lang="en-GB" sz="2000" kern="0" dirty="0">
+              <a:solidFill>
+                <a:srgbClr val="000000"/>
+              </a:solidFill>
+              <a:latin typeface="Arial"/>
+              <a:cs typeface="Arial"/>
+              <a:sym typeface="Arial"/>
+            </a:endParaRPr>
+          </a:p>
+        </p:txBody>
+      </p:sp>
+      <p:pic>
+        <p:nvPicPr>
+          <p:cNvPr id="8" name="Picture 7">
+            <a:extLst>
+              <a:ext uri="{FF2B5EF4-FFF2-40B4-BE49-F238E27FC236}">
+                <a16:creationId xmlns:a16="http://schemas.microsoft.com/office/drawing/2014/main" id="{830DCDB1-B6BB-E7E5-4E58-E24ACA2E2CD1}"/>
+              </a:ext>
+            </a:extLst>
+          </p:cNvPr>
+          <p:cNvPicPr>
+            <a:picLocks noChangeAspect="1"/>
+          </p:cNvPicPr>
+          <p:nvPr/>
+        </p:nvPicPr>
+        <p:blipFill>
+          <a:blip r:embed="rId3"/>
+          <a:stretch>
+            <a:fillRect/>
+          </a:stretch>
+        </p:blipFill>
+        <p:spPr>
+          <a:xfrm>
+            <a:off x="6340642" y="3921822"/>
+            <a:ext cx="10363200" cy="5678588"/>
+          </a:xfrm>
+          <a:prstGeom prst="rect">
+            <a:avLst/>
+          </a:prstGeom>
+        </p:spPr>
+      </p:pic>
+      <p:sp>
+        <p:nvSpPr>
+          <p:cNvPr id="10" name="TextBox 4">
+            <a:extLst>
+              <a:ext uri="{FF2B5EF4-FFF2-40B4-BE49-F238E27FC236}">
+                <a16:creationId xmlns:a16="http://schemas.microsoft.com/office/drawing/2014/main" id="{E61DA458-9549-4CE0-1784-7D0C8786786F}"/>
+              </a:ext>
+            </a:extLst>
+          </p:cNvPr>
+          <p:cNvSpPr txBox="1"/>
+          <p:nvPr/>
+        </p:nvSpPr>
+        <p:spPr>
+          <a:xfrm>
+            <a:off x="2398299" y="2214247"/>
+            <a:ext cx="5755101" cy="577081"/>
+          </a:xfrm>
+          <a:prstGeom prst="rect">
+            <a:avLst/>
+          </a:prstGeom>
+        </p:spPr>
+        <p:txBody>
+          <a:bodyPr wrap="square" lIns="0" tIns="0" rIns="0" bIns="0" rtlCol="0" anchor="t">
+            <a:spAutoFit/>
+          </a:bodyPr>
+          <a:lstStyle/>
+          <a:p>
+            <a:pPr algn="l">
+              <a:lnSpc>
+                <a:spcPts val="4542"/>
+              </a:lnSpc>
+            </a:pPr>
+            <a:r>
+              <a:rPr lang="en-US" sz="3785" b="1" dirty="0">
+                <a:solidFill>
+                  <a:srgbClr val="0E4714"/>
+                </a:solidFill>
+                <a:latin typeface="Gotham Bold"/>
+                <a:ea typeface="Gotham Bold"/>
+                <a:cs typeface="Gotham Bold"/>
+                <a:sym typeface="Gotham Bold"/>
+              </a:rPr>
+              <a:t>2. Problem Statement</a:t>
+            </a:r>
+          </a:p>
+        </p:txBody>
+      </p:sp>
+      <p:sp>
+        <p:nvSpPr>
+          <p:cNvPr id="12" name="Freeform 5">
+            <a:extLst>
+              <a:ext uri="{FF2B5EF4-FFF2-40B4-BE49-F238E27FC236}">
+                <a16:creationId xmlns:a16="http://schemas.microsoft.com/office/drawing/2014/main" id="{8C30EB6D-7DCA-0009-FCC4-50A3FFFF1DF2}"/>
+              </a:ext>
+            </a:extLst>
+          </p:cNvPr>
+          <p:cNvSpPr/>
+          <p:nvPr/>
+        </p:nvSpPr>
+        <p:spPr>
+          <a:xfrm>
+            <a:off x="1016407" y="2140619"/>
+            <a:ext cx="1296035" cy="1206933"/>
+          </a:xfrm>
+          <a:custGeom>
+            <a:avLst/>
+            <a:gdLst/>
+            <a:ahLst/>
+            <a:cxnLst/>
+            <a:rect l="l" t="t" r="r" b="b"/>
+            <a:pathLst>
+              <a:path w="1296035" h="1206933">
+                <a:moveTo>
+                  <a:pt x="0" y="0"/>
+                </a:moveTo>
+                <a:lnTo>
+                  <a:pt x="1296035" y="0"/>
+                </a:lnTo>
+                <a:lnTo>
+                  <a:pt x="1296035" y="1206932"/>
+                </a:lnTo>
+                <a:lnTo>
+                  <a:pt x="0" y="1206932"/>
+                </a:lnTo>
+                <a:lnTo>
+                  <a:pt x="0" y="0"/>
+                </a:lnTo>
+                <a:close/>
+              </a:path>
+            </a:pathLst>
+          </a:custGeom>
+          <a:blipFill>
+            <a:blip>
+              <a:extLst>
+                <a:ext uri="{96DAC541-7B7A-43D3-8B79-37D633B846F1}">
+                  <asvg:svgBlip xmlns:asvg="http://schemas.microsoft.com/office/drawing/2016/SVG/main" r:embed="rId4"/>
+                </a:ext>
+              </a:extLst>
+            </a:blip>
+            <a:stretch>
+              <a:fillRect/>
+            </a:stretch>
+          </a:blipFill>
+        </p:spPr>
+        <p:txBody>
+          <a:bodyPr/>
+          <a:lstStyle/>
+          <a:p>
+            <a:endParaRPr lang="en-GB"/>
+          </a:p>
+        </p:txBody>
+      </p:sp>
+      <p:pic>
+        <p:nvPicPr>
+          <p:cNvPr id="3" name="Google Shape;1608;p38" title="qhackathon_logo-removebg-preview.png">
+            <a:extLst>
+              <a:ext uri="{FF2B5EF4-FFF2-40B4-BE49-F238E27FC236}">
+                <a16:creationId xmlns:a16="http://schemas.microsoft.com/office/drawing/2014/main" id="{88AE012C-3AAD-CD3D-F3F4-BF5DDBF19279}"/>
+              </a:ext>
+            </a:extLst>
+          </p:cNvPr>
+          <p:cNvPicPr preferRelativeResize="0"/>
+          <p:nvPr/>
+        </p:nvPicPr>
+        <p:blipFill rotWithShape="1">
+          <a:blip r:embed="rId5">
+            <a:alphaModFix/>
+          </a:blip>
+          <a:srcRect t="5650" b="5650"/>
+          <a:stretch/>
+        </p:blipFill>
+        <p:spPr>
+          <a:xfrm>
+            <a:off x="16611600" y="0"/>
+            <a:ext cx="1676400" cy="1447800"/>
+          </a:xfrm>
+          <a:prstGeom prst="rect">
+            <a:avLst/>
+          </a:prstGeom>
+          <a:noFill/>
+          <a:ln>
+            <a:noFill/>
+          </a:ln>
+        </p:spPr>
+      </p:pic>
+      <p:sp>
+        <p:nvSpPr>
+          <p:cNvPr id="5" name="TextBox 4">
+            <a:extLst>
+              <a:ext uri="{FF2B5EF4-FFF2-40B4-BE49-F238E27FC236}">
+                <a16:creationId xmlns:a16="http://schemas.microsoft.com/office/drawing/2014/main" id="{9086D460-2096-6AE6-5A10-F5238B57BF8C}"/>
+              </a:ext>
+            </a:extLst>
+          </p:cNvPr>
+          <p:cNvSpPr txBox="1"/>
+          <p:nvPr/>
+        </p:nvSpPr>
+        <p:spPr>
+          <a:xfrm>
+            <a:off x="135799" y="4174004"/>
+            <a:ext cx="6036401" cy="1815882"/>
+          </a:xfrm>
+          <a:prstGeom prst="rect">
+            <a:avLst/>
+          </a:prstGeom>
+          <a:noFill/>
+        </p:spPr>
+        <p:txBody>
+          <a:bodyPr wrap="square">
+            <a:spAutoFit/>
+          </a:bodyPr>
+          <a:lstStyle/>
+          <a:p>
+            <a:pPr algn="justLow"/>
+            <a:r>
+              <a:rPr lang="en-GB" sz="2800" dirty="0">
+                <a:latin typeface="Abadi" panose="020B0604020104020204" pitchFamily="34" charset="0"/>
+              </a:rPr>
+              <a:t>Building and stress-testing a full QKD pipeline to securely exchange keys, detect eavesdroppers, and </a:t>
+            </a:r>
+            <a:r>
+              <a:rPr lang="en-GB" sz="2800" dirty="0" err="1">
+                <a:latin typeface="Abadi" panose="020B0604020104020204" pitchFamily="34" charset="0"/>
+              </a:rPr>
+              <a:t>distill</a:t>
+            </a:r>
+            <a:r>
+              <a:rPr lang="en-GB" sz="2800" dirty="0">
+                <a:latin typeface="Abadi" panose="020B0604020104020204" pitchFamily="34" charset="0"/>
+              </a:rPr>
+              <a:t> absolute cryptographic secrecy.</a:t>
+            </a:r>
+          </a:p>
+        </p:txBody>
+      </p:sp>
+    </p:spTree>
+  </p:cSld>
+  <p:clrMapOvr>
+    <a:masterClrMapping/>
+  </p:clrMapOvr>
+</p:sld>
+</file>
+
+<file path=ppt/slides/slide6.xml><?xml version="1.0" encoding="utf-8"?>
+<p:sld xmlns:a="http://schemas.openxmlformats.org/drawingml/2006/main" xmlns:r="http://schemas.openxmlformats.org/officeDocument/2006/relationships" xmlns:p="http://schemas.openxmlformats.org/presentationml/2006/main">
+  <p:cSld>
     <p:spTree>
       <p:nvGrpSpPr>
         <p:cNvPr id="1" name="">
@@ -12480,7 +12906,7 @@
                 <a:cs typeface="Gotham Bold"/>
                 <a:sym typeface="Gotham Bold"/>
               </a:rPr>
-              <a:t>2. BB84 Implementation Example</a:t>
+              <a:t>3. BB84 Implementation Example</a:t>
             </a:r>
           </a:p>
         </p:txBody>
@@ -12655,424 +13081,6 @@
         <p14:creationId xmlns:p14="http://schemas.microsoft.com/office/powerpoint/2010/main" val="2055683795"/>
       </p:ext>
     </p:extLst>
-  </p:cSld>
-  <p:clrMapOvr>
-    <a:masterClrMapping/>
-  </p:clrMapOvr>
-</p:sld>
-</file>
-
-<file path=ppt/slides/slide6.xml><?xml version="1.0" encoding="utf-8"?>
-<p:sld xmlns:a="http://schemas.openxmlformats.org/drawingml/2006/main" xmlns:r="http://schemas.openxmlformats.org/officeDocument/2006/relationships" xmlns:p="http://schemas.openxmlformats.org/presentationml/2006/main">
-  <p:cSld>
-    <p:bg>
-      <p:bgPr>
-        <a:solidFill>
-          <a:srgbClr val="E9EAE0"/>
-        </a:solidFill>
-        <a:effectLst/>
-      </p:bgPr>
-    </p:bg>
-    <p:spTree>
-      <p:nvGrpSpPr>
-        <p:cNvPr id="1" name=""/>
-        <p:cNvGrpSpPr/>
-        <p:nvPr/>
-      </p:nvGrpSpPr>
-      <p:grpSpPr>
-        <a:xfrm>
-          <a:off x="0" y="0"/>
-          <a:ext cx="0" cy="0"/>
-          <a:chOff x="0" y="0"/>
-          <a:chExt cx="0" cy="0"/>
-        </a:xfrm>
-      </p:grpSpPr>
-      <p:sp>
-        <p:nvSpPr>
-          <p:cNvPr id="4" name="Freeform 4"/>
-          <p:cNvSpPr/>
-          <p:nvPr/>
-        </p:nvSpPr>
-        <p:spPr>
-          <a:xfrm flipH="1">
-            <a:off x="11415085" y="-545920"/>
-            <a:ext cx="28550447" cy="11313545"/>
-          </a:xfrm>
-          <a:custGeom>
-            <a:avLst/>
-            <a:gdLst/>
-            <a:ahLst/>
-            <a:cxnLst/>
-            <a:rect l="l" t="t" r="r" b="b"/>
-            <a:pathLst>
-              <a:path w="28550447" h="11313545">
-                <a:moveTo>
-                  <a:pt x="28550447" y="0"/>
-                </a:moveTo>
-                <a:lnTo>
-                  <a:pt x="0" y="0"/>
-                </a:lnTo>
-                <a:lnTo>
-                  <a:pt x="0" y="11313545"/>
-                </a:lnTo>
-                <a:lnTo>
-                  <a:pt x="28550447" y="11313545"/>
-                </a:lnTo>
-                <a:lnTo>
-                  <a:pt x="28550447" y="0"/>
-                </a:lnTo>
-                <a:close/>
-              </a:path>
-            </a:pathLst>
-          </a:custGeom>
-          <a:blipFill>
-            <a:blip>
-              <a:extLst>
-                <a:ext uri="{96DAC541-7B7A-43D3-8B79-37D633B846F1}">
-                  <asvg:svgBlip xmlns:asvg="http://schemas.microsoft.com/office/drawing/2016/SVG/main" r:embed="rId2"/>
-                </a:ext>
-              </a:extLst>
-            </a:blip>
-            <a:stretch>
-              <a:fillRect t="-49969" b="-59256"/>
-            </a:stretch>
-          </a:blipFill>
-        </p:spPr>
-        <p:txBody>
-          <a:bodyPr/>
-          <a:lstStyle/>
-          <a:p>
-            <a:endParaRPr lang="en-GB"/>
-          </a:p>
-        </p:txBody>
-      </p:sp>
-      <p:sp>
-        <p:nvSpPr>
-          <p:cNvPr id="6" name="Google Shape;1606;p38">
-            <a:extLst>
-              <a:ext uri="{FF2B5EF4-FFF2-40B4-BE49-F238E27FC236}">
-                <a16:creationId xmlns:a16="http://schemas.microsoft.com/office/drawing/2014/main" id="{11940575-107A-ADA6-174F-56482EB05298}"/>
-              </a:ext>
-            </a:extLst>
-          </p:cNvPr>
-          <p:cNvSpPr txBox="1"/>
-          <p:nvPr/>
-        </p:nvSpPr>
-        <p:spPr>
-          <a:xfrm>
-            <a:off x="6324600" y="3004257"/>
-            <a:ext cx="7746330" cy="704636"/>
-          </a:xfrm>
-          <a:prstGeom prst="rect">
-            <a:avLst/>
-          </a:prstGeom>
-          <a:noFill/>
-          <a:ln>
-            <a:noFill/>
-          </a:ln>
-        </p:spPr>
-        <p:txBody>
-          <a:bodyPr spcFirstLastPara="1" wrap="square" lIns="121900" tIns="121900" rIns="121900" bIns="121900" anchor="t" anchorCtr="0">
-            <a:noAutofit/>
-          </a:bodyPr>
-          <a:lstStyle/>
-          <a:p>
-            <a:pPr algn="ctr" defTabSz="1219170">
-              <a:buClr>
-                <a:srgbClr val="000000"/>
-              </a:buClr>
-            </a:pPr>
-            <a:r>
-              <a:rPr lang="en-GB" sz="2800" b="1" kern="0" dirty="0">
-                <a:solidFill>
-                  <a:srgbClr val="000000"/>
-                </a:solidFill>
-                <a:latin typeface="Berlin Sans FB Demi" panose="020E0802020502020306" pitchFamily="34" charset="0"/>
-                <a:cs typeface="Arial"/>
-                <a:sym typeface="Arial"/>
-              </a:rPr>
-              <a:t>Build → Attack → Detect → </a:t>
-            </a:r>
-            <a:r>
-              <a:rPr lang="en-GB" sz="2800" b="1" kern="0" dirty="0" err="1">
-                <a:solidFill>
-                  <a:srgbClr val="000000"/>
-                </a:solidFill>
-                <a:latin typeface="Berlin Sans FB Demi" panose="020E0802020502020306" pitchFamily="34" charset="0"/>
-                <a:cs typeface="Arial"/>
-                <a:sym typeface="Arial"/>
-              </a:rPr>
-              <a:t>Distill</a:t>
-            </a:r>
-            <a:endParaRPr lang="en-GB" sz="2800" b="1" kern="0" dirty="0">
-              <a:solidFill>
-                <a:srgbClr val="000000"/>
-              </a:solidFill>
-              <a:latin typeface="Berlin Sans FB Demi" panose="020E0802020502020306" pitchFamily="34" charset="0"/>
-              <a:cs typeface="Arial"/>
-              <a:sym typeface="Arial"/>
-            </a:endParaRPr>
-          </a:p>
-          <a:p>
-            <a:pPr defTabSz="1219170">
-              <a:buClr>
-                <a:srgbClr val="000000"/>
-              </a:buClr>
-            </a:pPr>
-            <a:endParaRPr lang="en-GB" sz="2000" kern="0" dirty="0">
-              <a:solidFill>
-                <a:srgbClr val="000000"/>
-              </a:solidFill>
-              <a:latin typeface="Arial"/>
-              <a:cs typeface="Arial"/>
-              <a:sym typeface="Arial"/>
-            </a:endParaRPr>
-          </a:p>
-          <a:p>
-            <a:pPr marL="380990" indent="-380990" defTabSz="1219170">
-              <a:buClr>
-                <a:srgbClr val="000000"/>
-              </a:buClr>
-              <a:buFont typeface="Arial" panose="020B0604020202020204" pitchFamily="34" charset="0"/>
-              <a:buChar char="•"/>
-            </a:pPr>
-            <a:endParaRPr lang="en-GB" sz="2000" kern="0" dirty="0">
-              <a:solidFill>
-                <a:srgbClr val="000000"/>
-              </a:solidFill>
-              <a:latin typeface="Arial"/>
-              <a:cs typeface="Arial"/>
-              <a:sym typeface="Arial"/>
-            </a:endParaRPr>
-          </a:p>
-        </p:txBody>
-      </p:sp>
-      <p:pic>
-        <p:nvPicPr>
-          <p:cNvPr id="8" name="Picture 7">
-            <a:extLst>
-              <a:ext uri="{FF2B5EF4-FFF2-40B4-BE49-F238E27FC236}">
-                <a16:creationId xmlns:a16="http://schemas.microsoft.com/office/drawing/2014/main" id="{830DCDB1-B6BB-E7E5-4E58-E24ACA2E2CD1}"/>
-              </a:ext>
-            </a:extLst>
-          </p:cNvPr>
-          <p:cNvPicPr>
-            <a:picLocks noChangeAspect="1"/>
-          </p:cNvPicPr>
-          <p:nvPr/>
-        </p:nvPicPr>
-        <p:blipFill>
-          <a:blip r:embed="rId3"/>
-          <a:stretch>
-            <a:fillRect/>
-          </a:stretch>
-        </p:blipFill>
-        <p:spPr>
-          <a:xfrm>
-            <a:off x="6340642" y="3921822"/>
-            <a:ext cx="10363200" cy="5678588"/>
-          </a:xfrm>
-          <a:prstGeom prst="rect">
-            <a:avLst/>
-          </a:prstGeom>
-        </p:spPr>
-      </p:pic>
-      <p:sp>
-        <p:nvSpPr>
-          <p:cNvPr id="10" name="TextBox 4">
-            <a:extLst>
-              <a:ext uri="{FF2B5EF4-FFF2-40B4-BE49-F238E27FC236}">
-                <a16:creationId xmlns:a16="http://schemas.microsoft.com/office/drawing/2014/main" id="{E61DA458-9549-4CE0-1784-7D0C8786786F}"/>
-              </a:ext>
-            </a:extLst>
-          </p:cNvPr>
-          <p:cNvSpPr txBox="1"/>
-          <p:nvPr/>
-        </p:nvSpPr>
-        <p:spPr>
-          <a:xfrm>
-            <a:off x="2398299" y="2214247"/>
-            <a:ext cx="5755101" cy="577081"/>
-          </a:xfrm>
-          <a:prstGeom prst="rect">
-            <a:avLst/>
-          </a:prstGeom>
-        </p:spPr>
-        <p:txBody>
-          <a:bodyPr wrap="square" lIns="0" tIns="0" rIns="0" bIns="0" rtlCol="0" anchor="t">
-            <a:spAutoFit/>
-          </a:bodyPr>
-          <a:lstStyle/>
-          <a:p>
-            <a:pPr algn="l">
-              <a:lnSpc>
-                <a:spcPts val="4542"/>
-              </a:lnSpc>
-            </a:pPr>
-            <a:r>
-              <a:rPr lang="en-US" sz="3785" b="1" dirty="0">
-                <a:solidFill>
-                  <a:srgbClr val="0E4714"/>
-                </a:solidFill>
-                <a:latin typeface="Gotham Bold"/>
-                <a:ea typeface="Gotham Bold"/>
-                <a:cs typeface="Gotham Bold"/>
-                <a:sym typeface="Gotham Bold"/>
-              </a:rPr>
-              <a:t>3. Problem Statement</a:t>
-            </a:r>
-          </a:p>
-        </p:txBody>
-      </p:sp>
-      <p:sp>
-        <p:nvSpPr>
-          <p:cNvPr id="12" name="Freeform 5">
-            <a:extLst>
-              <a:ext uri="{FF2B5EF4-FFF2-40B4-BE49-F238E27FC236}">
-                <a16:creationId xmlns:a16="http://schemas.microsoft.com/office/drawing/2014/main" id="{8C30EB6D-7DCA-0009-FCC4-50A3FFFF1DF2}"/>
-              </a:ext>
-            </a:extLst>
-          </p:cNvPr>
-          <p:cNvSpPr/>
-          <p:nvPr/>
-        </p:nvSpPr>
-        <p:spPr>
-          <a:xfrm>
-            <a:off x="1016407" y="2140619"/>
-            <a:ext cx="1296035" cy="1206933"/>
-          </a:xfrm>
-          <a:custGeom>
-            <a:avLst/>
-            <a:gdLst/>
-            <a:ahLst/>
-            <a:cxnLst/>
-            <a:rect l="l" t="t" r="r" b="b"/>
-            <a:pathLst>
-              <a:path w="1296035" h="1206933">
-                <a:moveTo>
-                  <a:pt x="0" y="0"/>
-                </a:moveTo>
-                <a:lnTo>
-                  <a:pt x="1296035" y="0"/>
-                </a:lnTo>
-                <a:lnTo>
-                  <a:pt x="1296035" y="1206932"/>
-                </a:lnTo>
-                <a:lnTo>
-                  <a:pt x="0" y="1206932"/>
-                </a:lnTo>
-                <a:lnTo>
-                  <a:pt x="0" y="0"/>
-                </a:lnTo>
-                <a:close/>
-              </a:path>
-            </a:pathLst>
-          </a:custGeom>
-          <a:blipFill>
-            <a:blip>
-              <a:extLst>
-                <a:ext uri="{96DAC541-7B7A-43D3-8B79-37D633B846F1}">
-                  <asvg:svgBlip xmlns:asvg="http://schemas.microsoft.com/office/drawing/2016/SVG/main" r:embed="rId4"/>
-                </a:ext>
-              </a:extLst>
-            </a:blip>
-            <a:stretch>
-              <a:fillRect/>
-            </a:stretch>
-          </a:blipFill>
-        </p:spPr>
-        <p:txBody>
-          <a:bodyPr/>
-          <a:lstStyle/>
-          <a:p>
-            <a:endParaRPr lang="en-GB"/>
-          </a:p>
-        </p:txBody>
-      </p:sp>
-      <p:pic>
-        <p:nvPicPr>
-          <p:cNvPr id="3" name="Google Shape;1608;p38" title="qhackathon_logo-removebg-preview.png">
-            <a:extLst>
-              <a:ext uri="{FF2B5EF4-FFF2-40B4-BE49-F238E27FC236}">
-                <a16:creationId xmlns:a16="http://schemas.microsoft.com/office/drawing/2014/main" id="{88AE012C-3AAD-CD3D-F3F4-BF5DDBF19279}"/>
-              </a:ext>
-            </a:extLst>
-          </p:cNvPr>
-          <p:cNvPicPr preferRelativeResize="0"/>
-          <p:nvPr/>
-        </p:nvPicPr>
-        <p:blipFill rotWithShape="1">
-          <a:blip r:embed="rId5">
-            <a:alphaModFix/>
-          </a:blip>
-          <a:srcRect t="5650" b="5650"/>
-          <a:stretch/>
-        </p:blipFill>
-        <p:spPr>
-          <a:xfrm>
-            <a:off x="16611600" y="0"/>
-            <a:ext cx="1676400" cy="1447800"/>
-          </a:xfrm>
-          <a:prstGeom prst="rect">
-            <a:avLst/>
-          </a:prstGeom>
-          <a:noFill/>
-          <a:ln>
-            <a:noFill/>
-          </a:ln>
-        </p:spPr>
-      </p:pic>
-      <p:sp>
-        <p:nvSpPr>
-          <p:cNvPr id="5" name="TextBox 4">
-            <a:extLst>
-              <a:ext uri="{FF2B5EF4-FFF2-40B4-BE49-F238E27FC236}">
-                <a16:creationId xmlns:a16="http://schemas.microsoft.com/office/drawing/2014/main" id="{9086D460-2096-6AE6-5A10-F5238B57BF8C}"/>
-              </a:ext>
-            </a:extLst>
-          </p:cNvPr>
-          <p:cNvSpPr txBox="1"/>
-          <p:nvPr/>
-        </p:nvSpPr>
-        <p:spPr>
-          <a:xfrm>
-            <a:off x="135799" y="4174004"/>
-            <a:ext cx="6036401" cy="1815882"/>
-          </a:xfrm>
-          <a:prstGeom prst="rect">
-            <a:avLst/>
-          </a:prstGeom>
-          <a:noFill/>
-        </p:spPr>
-        <p:txBody>
-          <a:bodyPr wrap="square">
-            <a:spAutoFit/>
-          </a:bodyPr>
-          <a:lstStyle/>
-          <a:p>
-            <a:pPr algn="justLow"/>
-            <a:r>
-              <a:rPr lang="en-GB" sz="2800" dirty="0">
-                <a:latin typeface="Abadi" panose="020B0604020104020204" pitchFamily="34" charset="0"/>
-              </a:rPr>
-              <a:t>Building and stress-testing a full QKD pipeline to securely exchange keys, detect eavesdroppers, and </a:t>
-            </a:r>
-            <a:r>
-              <a:rPr lang="en-GB" sz="2800" dirty="0" err="1">
-                <a:latin typeface="Abadi" panose="020B0604020104020204" pitchFamily="34" charset="0"/>
-              </a:rPr>
-              <a:t>distill</a:t>
-            </a:r>
-            <a:r>
-              <a:rPr lang="en-GB" sz="2800" dirty="0">
-                <a:latin typeface="Abadi" panose="020B0604020104020204" pitchFamily="34" charset="0"/>
-              </a:rPr>
-              <a:t> absolute cryptographic secrecy.</a:t>
-            </a:r>
-          </a:p>
-        </p:txBody>
-      </p:sp>
-    </p:spTree>
   </p:cSld>
   <p:clrMapOvr>
     <a:masterClrMapping/>
@@ -14105,7 +14113,7 @@
         <p:spPr>
           <a:xfrm>
             <a:off x="8719796" y="8880197"/>
-            <a:ext cx="8174364" cy="830997"/>
+            <a:ext cx="8174364" cy="461665"/>
           </a:xfrm>
           <a:prstGeom prst="rect">
             <a:avLst/>
@@ -14121,15 +14129,7 @@
             <a:pPr algn="ctr"/>
             <a:r>
               <a:rPr lang="en-GB" sz="2400" b="1" dirty="0"/>
-              <a:t>Figure 4. Illustrates key generation speed dropping to zero near eta</a:t>
-            </a:r>
-            <a:r>
-              <a:rPr lang="ar-EG" sz="2400" b="1" dirty="0"/>
-              <a:t>~</a:t>
-            </a:r>
-            <a:r>
-              <a:rPr lang="en-GB" sz="2400" b="1" dirty="0"/>
-              <a:t>0.44$. </a:t>
+              <a:t>Figure 4. Illustrates key generation speed.</a:t>
             </a:r>
           </a:p>
         </p:txBody>

</xml_diff>